<commit_message>
Update from Peak to Feature
</commit_message>
<xml_diff>
--- a/res/tidyData.pptx
+++ b/res/tidyData.pptx
@@ -247,7 +247,7 @@
           <a:p>
             <a:fld id="{DDEC7F33-7302-E647-9070-C6BD1608D5F5}" type="datetimeFigureOut">
               <a:rPr lang="en-US" smtClean="0"/>
-              <a:t>5/1/24</a:t>
+              <a:t>6/3/26</a:t>
             </a:fld>
             <a:endParaRPr lang="en-US"/>
           </a:p>
@@ -417,7 +417,7 @@
           <a:p>
             <a:fld id="{DDEC7F33-7302-E647-9070-C6BD1608D5F5}" type="datetimeFigureOut">
               <a:rPr lang="en-US" smtClean="0"/>
-              <a:t>5/1/24</a:t>
+              <a:t>6/3/26</a:t>
             </a:fld>
             <a:endParaRPr lang="en-US"/>
           </a:p>
@@ -597,7 +597,7 @@
           <a:p>
             <a:fld id="{DDEC7F33-7302-E647-9070-C6BD1608D5F5}" type="datetimeFigureOut">
               <a:rPr lang="en-US" smtClean="0"/>
-              <a:t>5/1/24</a:t>
+              <a:t>6/3/26</a:t>
             </a:fld>
             <a:endParaRPr lang="en-US"/>
           </a:p>
@@ -767,7 +767,7 @@
           <a:p>
             <a:fld id="{DDEC7F33-7302-E647-9070-C6BD1608D5F5}" type="datetimeFigureOut">
               <a:rPr lang="en-US" smtClean="0"/>
-              <a:t>5/1/24</a:t>
+              <a:t>6/3/26</a:t>
             </a:fld>
             <a:endParaRPr lang="en-US"/>
           </a:p>
@@ -1013,7 +1013,7 @@
           <a:p>
             <a:fld id="{DDEC7F33-7302-E647-9070-C6BD1608D5F5}" type="datetimeFigureOut">
               <a:rPr lang="en-US" smtClean="0"/>
-              <a:t>5/1/24</a:t>
+              <a:t>6/3/26</a:t>
             </a:fld>
             <a:endParaRPr lang="en-US"/>
           </a:p>
@@ -1245,7 +1245,7 @@
           <a:p>
             <a:fld id="{DDEC7F33-7302-E647-9070-C6BD1608D5F5}" type="datetimeFigureOut">
               <a:rPr lang="en-US" smtClean="0"/>
-              <a:t>5/1/24</a:t>
+              <a:t>6/3/26</a:t>
             </a:fld>
             <a:endParaRPr lang="en-US"/>
           </a:p>
@@ -1612,7 +1612,7 @@
           <a:p>
             <a:fld id="{DDEC7F33-7302-E647-9070-C6BD1608D5F5}" type="datetimeFigureOut">
               <a:rPr lang="en-US" smtClean="0"/>
-              <a:t>5/1/24</a:t>
+              <a:t>6/3/26</a:t>
             </a:fld>
             <a:endParaRPr lang="en-US"/>
           </a:p>
@@ -1730,7 +1730,7 @@
           <a:p>
             <a:fld id="{DDEC7F33-7302-E647-9070-C6BD1608D5F5}" type="datetimeFigureOut">
               <a:rPr lang="en-US" smtClean="0"/>
-              <a:t>5/1/24</a:t>
+              <a:t>6/3/26</a:t>
             </a:fld>
             <a:endParaRPr lang="en-US"/>
           </a:p>
@@ -1825,7 +1825,7 @@
           <a:p>
             <a:fld id="{DDEC7F33-7302-E647-9070-C6BD1608D5F5}" type="datetimeFigureOut">
               <a:rPr lang="en-US" smtClean="0"/>
-              <a:t>5/1/24</a:t>
+              <a:t>6/3/26</a:t>
             </a:fld>
             <a:endParaRPr lang="en-US"/>
           </a:p>
@@ -2102,7 +2102,7 @@
           <a:p>
             <a:fld id="{DDEC7F33-7302-E647-9070-C6BD1608D5F5}" type="datetimeFigureOut">
               <a:rPr lang="en-US" smtClean="0"/>
-              <a:t>5/1/24</a:t>
+              <a:t>6/3/26</a:t>
             </a:fld>
             <a:endParaRPr lang="en-US"/>
           </a:p>
@@ -2359,7 +2359,7 @@
           <a:p>
             <a:fld id="{DDEC7F33-7302-E647-9070-C6BD1608D5F5}" type="datetimeFigureOut">
               <a:rPr lang="en-US" smtClean="0"/>
-              <a:t>5/1/24</a:t>
+              <a:t>6/3/26</a:t>
             </a:fld>
             <a:endParaRPr lang="en-US"/>
           </a:p>
@@ -2572,7 +2572,7 @@
           <a:p>
             <a:fld id="{DDEC7F33-7302-E647-9070-C6BD1608D5F5}" type="datetimeFigureOut">
               <a:rPr lang="en-US" smtClean="0"/>
-              <a:t>5/1/24</a:t>
+              <a:t>6/3/26</a:t>
             </a:fld>
             <a:endParaRPr lang="en-US"/>
           </a:p>
@@ -2653,6 +2653,54 @@
               <a:t>‹#›</a:t>
             </a:fld>
             <a:endParaRPr lang="en-US"/>
+          </a:p>
+        </p:txBody>
+      </p:sp>
+      <p:sp>
+        <p:nvSpPr>
+          <p:cNvPr id="8" name="TextBox 7">
+            <a:extLst>
+              <a:ext uri="{FF2B5EF4-FFF2-40B4-BE49-F238E27FC236}">
+                <a16:creationId xmlns:a16="http://schemas.microsoft.com/office/drawing/2014/main" id="{4D499D85-4D48-5760-9E12-9FD7EED05512}"/>
+              </a:ext>
+            </a:extLst>
+          </p:cNvPr>
+          <p:cNvSpPr txBox="1"/>
+          <p:nvPr userDrawn="1">
+            <p:extLst>
+              <p:ext uri="{1162E1C5-73C7-4A58-AE30-91384D911F3F}">
+                <p184:classification xmlns:p184="http://schemas.microsoft.com/office/powerpoint/2018/4/main" val="ftr"/>
+              </p:ext>
+            </p:extLst>
+          </p:nvPr>
+        </p:nvSpPr>
+        <p:spPr>
+          <a:xfrm>
+            <a:off x="7282625" y="6611620"/>
+            <a:ext cx="1666875" cy="182880"/>
+          </a:xfrm>
+          <a:prstGeom prst="rect">
+            <a:avLst/>
+          </a:prstGeom>
+        </p:spPr>
+        <p:txBody>
+          <a:bodyPr horzOverflow="overflow" lIns="0" tIns="0" rIns="0" bIns="0">
+            <a:spAutoFit/>
+          </a:bodyPr>
+          <a:lstStyle/>
+          <a:p>
+            <a:pPr algn="l"/>
+            <a:r>
+              <a:rPr lang="en-US" sz="1200">
+                <a:solidFill>
+                  <a:srgbClr val="000000">
+                    <a:alpha val="50000"/>
+                  </a:srgbClr>
+                </a:solidFill>
+                <a:latin typeface="Aptos" panose="020B0004020202020204" pitchFamily="34" charset="0"/>
+              </a:rPr>
+              <a:t>ECU Internal Information</a:t>
+            </a:r>
           </a:p>
         </p:txBody>
       </p:sp>
@@ -3370,7 +3418,7 @@
         <p:spPr>
           <a:xfrm>
             <a:off x="2556191" y="3875470"/>
-            <a:ext cx="1175706" cy="369332"/>
+            <a:ext cx="1489716" cy="369332"/>
           </a:xfrm>
           <a:prstGeom prst="rect">
             <a:avLst/>
@@ -3384,9 +3432,10 @@
           <a:lstStyle/>
           <a:p>
             <a:r>
-              <a:rPr lang="en-US" dirty="0"/>
-              <a:t>PeakTable</a:t>
+              <a:rPr lang="en-US" dirty="0" err="1"/>
+              <a:t>FeatureTable</a:t>
             </a:r>
+            <a:endParaRPr lang="en-US" dirty="0"/>
           </a:p>
         </p:txBody>
       </p:sp>
@@ -3952,9 +4001,10 @@
           <a:lstStyle/>
           <a:p>
             <a:r>
-              <a:rPr lang="en-US" dirty="0"/>
-              <a:t>PeakTable</a:t>
+              <a:rPr lang="en-US" dirty="0" err="1"/>
+              <a:t>FeatureTable</a:t>
             </a:r>
+            <a:endParaRPr lang="en-US" dirty="0"/>
           </a:p>
         </p:txBody>
       </p:sp>

</xml_diff>